<commit_message>
Thumbnails for new video
</commit_message>
<xml_diff>
--- a/2026/20260301-WhatIsSuperposition.pptx
+++ b/2026/20260301-WhatIsSuperposition.pptx
@@ -210,7 +210,7 @@
           <a:p>
             <a:fld id="{E119C704-B8F9-449B-B828-36D786A1FE73}" type="datetimeFigureOut">
               <a:rPr lang="en-US" smtClean="0"/>
-              <a:t>2/26/2026</a:t>
+              <a:t>2/28/2026</a:t>
             </a:fld>
             <a:endParaRPr lang="en-US"/>
           </a:p>
@@ -477,6 +477,96 @@
 </p:notesMaster>
 </file>
 
+<file path=ppt/notesSlides/notesSlide1.xml><?xml version="1.0" encoding="utf-8"?>
+<p:notes xmlns:a="http://schemas.openxmlformats.org/drawingml/2006/main" xmlns:r="http://schemas.openxmlformats.org/officeDocument/2006/relationships" xmlns:p="http://schemas.openxmlformats.org/presentationml/2006/main">
+  <p:cSld>
+    <p:spTree>
+      <p:nvGrpSpPr>
+        <p:cNvPr id="1" name=""/>
+        <p:cNvGrpSpPr/>
+        <p:nvPr/>
+      </p:nvGrpSpPr>
+      <p:grpSpPr>
+        <a:xfrm>
+          <a:off x="0" y="0"/>
+          <a:ext cx="0" cy="0"/>
+          <a:chOff x="0" y="0"/>
+          <a:chExt cx="0" cy="0"/>
+        </a:xfrm>
+      </p:grpSpPr>
+      <p:sp>
+        <p:nvSpPr>
+          <p:cNvPr id="2" name="Slide Image Placeholder 1"/>
+          <p:cNvSpPr>
+            <a:spLocks noGrp="1" noRot="1" noChangeAspect="1"/>
+          </p:cNvSpPr>
+          <p:nvPr>
+            <p:ph type="sldImg"/>
+          </p:nvPr>
+        </p:nvSpPr>
+        <p:spPr/>
+      </p:sp>
+      <p:sp>
+        <p:nvSpPr>
+          <p:cNvPr id="3" name="Notes Placeholder 2"/>
+          <p:cNvSpPr>
+            <a:spLocks noGrp="1"/>
+          </p:cNvSpPr>
+          <p:nvPr>
+            <p:ph type="body" idx="1"/>
+          </p:nvPr>
+        </p:nvSpPr>
+        <p:spPr/>
+        <p:txBody>
+          <a:bodyPr/>
+          <a:lstStyle/>
+          <a:p>
+            <a:r>
+              <a:rPr lang="en-US" dirty="0"/>
+              <a:t>Superpositions! One of the most mischaracterized features of quantum mechanics. Quantum systems can be in a superposition state, where they are in multiple states at once before you measure! No. So, first we are going to see that quantum systems are always in a single state and that there are no “superposition states,” though you can express any state as a superposition, a linear combination, of others. Just like you do for vectors that describe directions in space. Then we are going to see how and, most importantly, why the linearity we use for directions in space is different than the linearity we use for quantum states, why we often “divide angles by two” in quantum mechanics and why we use complex linear combinations. So, let’s do it!</a:t>
+            </a:r>
+          </a:p>
+          <a:p>
+            <a:endParaRPr lang="en-US" dirty="0"/>
+          </a:p>
+        </p:txBody>
+      </p:sp>
+      <p:sp>
+        <p:nvSpPr>
+          <p:cNvPr id="4" name="Slide Number Placeholder 3"/>
+          <p:cNvSpPr>
+            <a:spLocks noGrp="1"/>
+          </p:cNvSpPr>
+          <p:nvPr>
+            <p:ph type="sldNum" sz="quarter" idx="5"/>
+          </p:nvPr>
+        </p:nvSpPr>
+        <p:spPr/>
+        <p:txBody>
+          <a:bodyPr/>
+          <a:lstStyle/>
+          <a:p>
+            <a:fld id="{A154F452-85BD-4268-B680-C313DBFDCEB3}" type="slidenum">
+              <a:rPr lang="en-US" smtClean="0"/>
+              <a:t>1</a:t>
+            </a:fld>
+            <a:endParaRPr lang="en-US"/>
+          </a:p>
+        </p:txBody>
+      </p:sp>
+    </p:spTree>
+    <p:extLst>
+      <p:ext uri="{BB962C8B-B14F-4D97-AF65-F5344CB8AC3E}">
+        <p14:creationId xmlns:p14="http://schemas.microsoft.com/office/powerpoint/2010/main" val="1810690064"/>
+      </p:ext>
+    </p:extLst>
+  </p:cSld>
+  <p:clrMapOvr>
+    <a:masterClrMapping/>
+  </p:clrMapOvr>
+</p:notes>
+</file>
+
 <file path=ppt/slideLayouts/slideLayout1.xml><?xml version="1.0" encoding="utf-8"?>
 <p:sldLayout xmlns:a="http://schemas.openxmlformats.org/drawingml/2006/main" xmlns:r="http://schemas.openxmlformats.org/officeDocument/2006/relationships" xmlns:p="http://schemas.openxmlformats.org/presentationml/2006/main" showMasterSp="0" type="title" preserve="1">
   <p:cSld name="Title Slide">
@@ -624,7 +714,7 @@
           <a:p>
             <a:fld id="{46E33BD1-BDB8-4376-AAF8-3A003435480C}" type="datetime1">
               <a:rPr lang="en-US" smtClean="0"/>
-              <a:t>2/26/2026</a:t>
+              <a:t>2/28/2026</a:t>
             </a:fld>
             <a:endParaRPr lang="en-US"/>
           </a:p>
@@ -1128,7 +1218,7 @@
           <a:p>
             <a:fld id="{C06845AE-F78C-47ED-986D-2F5B5C247549}" type="datetime1">
               <a:rPr lang="en-US" smtClean="0"/>
-              <a:t>2/26/2026</a:t>
+              <a:t>2/28/2026</a:t>
             </a:fld>
             <a:endParaRPr lang="en-US"/>
           </a:p>
@@ -1339,7 +1429,7 @@
           <a:p>
             <a:fld id="{95AFA110-3775-4B6B-91E5-6049BB8CC0F2}" type="datetime1">
               <a:rPr lang="en-US" smtClean="0"/>
-              <a:t>2/26/2026</a:t>
+              <a:t>2/28/2026</a:t>
             </a:fld>
             <a:endParaRPr lang="en-US"/>
           </a:p>
@@ -1568,7 +1658,7 @@
           <a:p>
             <a:fld id="{62632B5B-3D6C-4612-9889-D56772AB65F7}" type="datetime1">
               <a:rPr lang="en-US" smtClean="0"/>
-              <a:t>2/26/2026</a:t>
+              <a:t>2/28/2026</a:t>
             </a:fld>
             <a:endParaRPr lang="en-US" dirty="0"/>
           </a:p>
@@ -1818,7 +1908,7 @@
           <a:p>
             <a:fld id="{489234EC-2A19-44A7-B16B-2575145E773E}" type="datetime1">
               <a:rPr lang="en-US" smtClean="0"/>
-              <a:t>2/26/2026</a:t>
+              <a:t>2/28/2026</a:t>
             </a:fld>
             <a:endParaRPr lang="en-US"/>
           </a:p>
@@ -2086,7 +2176,7 @@
           <a:p>
             <a:fld id="{4205EDB3-4761-4B82-865F-A5EEEFDA670E}" type="datetime1">
               <a:rPr lang="en-US" smtClean="0"/>
-              <a:t>2/26/2026</a:t>
+              <a:t>2/28/2026</a:t>
             </a:fld>
             <a:endParaRPr lang="en-US"/>
           </a:p>
@@ -2501,7 +2591,7 @@
           <a:p>
             <a:fld id="{5BB56CE5-357E-4369-9BE4-05AD9FAD5660}" type="datetime1">
               <a:rPr lang="en-US" smtClean="0"/>
-              <a:t>2/26/2026</a:t>
+              <a:t>2/28/2026</a:t>
             </a:fld>
             <a:endParaRPr lang="en-US"/>
           </a:p>
@@ -2645,7 +2735,7 @@
           <a:p>
             <a:fld id="{9EDE89CB-A9F6-477A-A4C2-11E3149C3A97}" type="datetime1">
               <a:rPr lang="en-US" smtClean="0"/>
-              <a:t>2/26/2026</a:t>
+              <a:t>2/28/2026</a:t>
             </a:fld>
             <a:endParaRPr lang="en-US"/>
           </a:p>
@@ -2761,7 +2851,7 @@
           <a:p>
             <a:fld id="{6F4E52C4-4608-40F5-9B8E-BEEB48B105B6}" type="datetime1">
               <a:rPr lang="en-US" smtClean="0"/>
-              <a:t>2/26/2026</a:t>
+              <a:t>2/28/2026</a:t>
             </a:fld>
             <a:endParaRPr lang="en-US" dirty="0"/>
           </a:p>
@@ -3076,7 +3166,7 @@
           <a:p>
             <a:fld id="{56CDB743-5423-42F1-9DC7-FD2205F9F888}" type="datetime1">
               <a:rPr lang="en-US" smtClean="0"/>
-              <a:t>2/26/2026</a:t>
+              <a:t>2/28/2026</a:t>
             </a:fld>
             <a:endParaRPr lang="en-US"/>
           </a:p>
@@ -3367,7 +3457,7 @@
           <a:p>
             <a:fld id="{5AAF03F7-4D9C-4471-819E-E2C49033A744}" type="datetime1">
               <a:rPr lang="en-US" smtClean="0"/>
-              <a:t>2/26/2026</a:t>
+              <a:t>2/28/2026</a:t>
             </a:fld>
             <a:endParaRPr lang="en-US"/>
           </a:p>
@@ -3611,7 +3701,7 @@
           <a:p>
             <a:fld id="{0A85AB10-52F0-434A-B1D5-C9C9261256B7}" type="datetime1">
               <a:rPr lang="en-US" smtClean="0"/>
-              <a:t>2/26/2026</a:t>
+              <a:t>2/28/2026</a:t>
             </a:fld>
             <a:endParaRPr lang="en-US" dirty="0"/>
           </a:p>
@@ -4650,7 +4740,7 @@
                 <a:avLst/>
               </a:prstGeom>
               <a:blipFill>
-                <a:blip r:embed="rId2"/>
+                <a:blip r:embed="rId3"/>
                 <a:stretch>
                   <a:fillRect/>
                 </a:stretch>
@@ -4789,7 +4879,7 @@
                 <a:avLst/>
               </a:prstGeom>
               <a:blipFill>
-                <a:blip r:embed="rId3"/>
+                <a:blip r:embed="rId4"/>
                 <a:stretch>
                   <a:fillRect/>
                 </a:stretch>
@@ -5079,7 +5169,7 @@
                   <a:avLst/>
                 </a:prstGeom>
                 <a:blipFill>
-                  <a:blip r:embed="rId4"/>
+                  <a:blip r:embed="rId5"/>
                   <a:stretch>
                     <a:fillRect b="-13115"/>
                   </a:stretch>
@@ -5311,7 +5401,7 @@
                   <a:avLst/>
                 </a:prstGeom>
                 <a:blipFill>
-                  <a:blip r:embed="rId5"/>
+                  <a:blip r:embed="rId6"/>
                   <a:stretch>
                     <a:fillRect/>
                   </a:stretch>
@@ -5588,7 +5678,7 @@
                   <a:avLst/>
                 </a:prstGeom>
                 <a:blipFill>
-                  <a:blip r:embed="rId6"/>
+                  <a:blip r:embed="rId7"/>
                   <a:stretch>
                     <a:fillRect/>
                   </a:stretch>
@@ -5820,7 +5910,7 @@
                   <a:avLst/>
                 </a:prstGeom>
                 <a:blipFill>
-                  <a:blip r:embed="rId7"/>
+                  <a:blip r:embed="rId8"/>
                   <a:stretch>
                     <a:fillRect/>
                   </a:stretch>
@@ -5916,7 +6006,7 @@
                   <a:avLst/>
                 </a:prstGeom>
                 <a:blipFill>
-                  <a:blip r:embed="rId8"/>
+                  <a:blip r:embed="rId9"/>
                   <a:stretch>
                     <a:fillRect/>
                   </a:stretch>
@@ -6012,7 +6102,7 @@
                   <a:avLst/>
                 </a:prstGeom>
                 <a:blipFill>
-                  <a:blip r:embed="rId9"/>
+                  <a:blip r:embed="rId10"/>
                   <a:stretch>
                     <a:fillRect/>
                   </a:stretch>
@@ -6939,7 +7029,7 @@
                     <a:avLst/>
                   </a:prstGeom>
                   <a:blipFill>
-                    <a:blip r:embed="rId10"/>
+                    <a:blip r:embed="rId11"/>
                     <a:stretch>
                       <a:fillRect/>
                     </a:stretch>
@@ -7082,7 +7172,7 @@
                     <a:avLst/>
                   </a:prstGeom>
                   <a:blipFill>
-                    <a:blip r:embed="rId11"/>
+                    <a:blip r:embed="rId12"/>
                     <a:stretch>
                       <a:fillRect/>
                     </a:stretch>
@@ -11798,8 +11888,8 @@
           </mc:Fallback>
         </mc:AlternateContent>
       </p:grpSp>
-      <mc:AlternateContent xmlns:mc="http://schemas.openxmlformats.org/markup-compatibility/2006">
-        <mc:Choice xmlns:a14="http://schemas.microsoft.com/office/drawing/2010/main" Requires="a14">
+      <mc:AlternateContent xmlns:mc="http://schemas.openxmlformats.org/markup-compatibility/2006" xmlns:a14="http://schemas.microsoft.com/office/drawing/2010/main">
+        <mc:Choice Requires="a14">
           <p:sp>
             <p:nvSpPr>
               <p:cNvPr id="11" name="TextBox 10">
@@ -11880,7 +11970,7 @@
             </p:txBody>
           </p:sp>
         </mc:Choice>
-        <mc:Fallback>
+        <mc:Fallback xmlns="">
           <p:sp>
             <p:nvSpPr>
               <p:cNvPr id="11" name="TextBox 10">
@@ -11925,8 +12015,8 @@
           </p:sp>
         </mc:Fallback>
       </mc:AlternateContent>
-      <mc:AlternateContent xmlns:mc="http://schemas.openxmlformats.org/markup-compatibility/2006">
-        <mc:Choice xmlns:a14="http://schemas.microsoft.com/office/drawing/2010/main" Requires="a14">
+      <mc:AlternateContent xmlns:mc="http://schemas.openxmlformats.org/markup-compatibility/2006" xmlns:a14="http://schemas.microsoft.com/office/drawing/2010/main">
+        <mc:Choice Requires="a14">
           <p:sp>
             <p:nvSpPr>
               <p:cNvPr id="12" name="TextBox 11">
@@ -12007,7 +12097,7 @@
             </p:txBody>
           </p:sp>
         </mc:Choice>
-        <mc:Fallback>
+        <mc:Fallback xmlns="">
           <p:sp>
             <p:nvSpPr>
               <p:cNvPr id="12" name="TextBox 11">
@@ -12052,8 +12142,8 @@
           </p:sp>
         </mc:Fallback>
       </mc:AlternateContent>
-      <mc:AlternateContent xmlns:mc="http://schemas.openxmlformats.org/markup-compatibility/2006">
-        <mc:Choice xmlns:a14="http://schemas.microsoft.com/office/drawing/2010/main" Requires="a14">
+      <mc:AlternateContent xmlns:mc="http://schemas.openxmlformats.org/markup-compatibility/2006" xmlns:a14="http://schemas.microsoft.com/office/drawing/2010/main">
+        <mc:Choice Requires="a14">
           <p:sp>
             <p:nvSpPr>
               <p:cNvPr id="13" name="TextBox 12">
@@ -12134,7 +12224,7 @@
             </p:txBody>
           </p:sp>
         </mc:Choice>
-        <mc:Fallback>
+        <mc:Fallback xmlns="">
           <p:sp>
             <p:nvSpPr>
               <p:cNvPr id="13" name="TextBox 12">
@@ -12179,8 +12269,8 @@
           </p:sp>
         </mc:Fallback>
       </mc:AlternateContent>
-      <mc:AlternateContent xmlns:mc="http://schemas.openxmlformats.org/markup-compatibility/2006">
-        <mc:Choice xmlns:a14="http://schemas.microsoft.com/office/drawing/2010/main" Requires="a14">
+      <mc:AlternateContent xmlns:mc="http://schemas.openxmlformats.org/markup-compatibility/2006" xmlns:a14="http://schemas.microsoft.com/office/drawing/2010/main">
+        <mc:Choice Requires="a14">
           <p:sp>
             <p:nvSpPr>
               <p:cNvPr id="14" name="TextBox 13">
@@ -12261,7 +12351,7 @@
             </p:txBody>
           </p:sp>
         </mc:Choice>
-        <mc:Fallback>
+        <mc:Fallback xmlns="">
           <p:sp>
             <p:nvSpPr>
               <p:cNvPr id="14" name="TextBox 13">
@@ -12306,8 +12396,8 @@
           </p:sp>
         </mc:Fallback>
       </mc:AlternateContent>
-      <mc:AlternateContent xmlns:mc="http://schemas.openxmlformats.org/markup-compatibility/2006">
-        <mc:Choice xmlns:a14="http://schemas.microsoft.com/office/drawing/2010/main" Requires="a14">
+      <mc:AlternateContent xmlns:mc="http://schemas.openxmlformats.org/markup-compatibility/2006" xmlns:a14="http://schemas.microsoft.com/office/drawing/2010/main">
+        <mc:Choice Requires="a14">
           <p:sp>
             <p:nvSpPr>
               <p:cNvPr id="15" name="TextBox 14">
@@ -12388,7 +12478,7 @@
             </p:txBody>
           </p:sp>
         </mc:Choice>
-        <mc:Fallback>
+        <mc:Fallback xmlns="">
           <p:sp>
             <p:nvSpPr>
               <p:cNvPr id="15" name="TextBox 14">
@@ -12433,8 +12523,8 @@
           </p:sp>
         </mc:Fallback>
       </mc:AlternateContent>
-      <mc:AlternateContent xmlns:mc="http://schemas.openxmlformats.org/markup-compatibility/2006">
-        <mc:Choice xmlns:a14="http://schemas.microsoft.com/office/drawing/2010/main" Requires="a14">
+      <mc:AlternateContent xmlns:mc="http://schemas.openxmlformats.org/markup-compatibility/2006" xmlns:a14="http://schemas.microsoft.com/office/drawing/2010/main">
+        <mc:Choice Requires="a14">
           <p:sp>
             <p:nvSpPr>
               <p:cNvPr id="16" name="TextBox 15">
@@ -12515,7 +12605,7 @@
             </p:txBody>
           </p:sp>
         </mc:Choice>
-        <mc:Fallback>
+        <mc:Fallback xmlns="">
           <p:sp>
             <p:nvSpPr>
               <p:cNvPr id="16" name="TextBox 15">
@@ -12560,8 +12650,8 @@
           </p:sp>
         </mc:Fallback>
       </mc:AlternateContent>
-      <mc:AlternateContent xmlns:mc="http://schemas.openxmlformats.org/markup-compatibility/2006">
-        <mc:Choice xmlns:a14="http://schemas.microsoft.com/office/drawing/2010/main" Requires="a14">
+      <mc:AlternateContent xmlns:mc="http://schemas.openxmlformats.org/markup-compatibility/2006" xmlns:a14="http://schemas.microsoft.com/office/drawing/2010/main">
+        <mc:Choice Requires="a14">
           <p:sp>
             <p:nvSpPr>
               <p:cNvPr id="57" name="TextBox 56">
@@ -12887,7 +12977,7 @@
             </p:txBody>
           </p:sp>
         </mc:Choice>
-        <mc:Fallback>
+        <mc:Fallback xmlns="">
           <p:sp>
             <p:nvSpPr>
               <p:cNvPr id="57" name="TextBox 56">
@@ -13133,8 +13223,8 @@
           </p:txBody>
         </p:sp>
       </p:grpSp>
-      <mc:AlternateContent xmlns:mc="http://schemas.openxmlformats.org/markup-compatibility/2006">
-        <mc:Choice xmlns:a14="http://schemas.microsoft.com/office/drawing/2010/main" Requires="a14">
+      <mc:AlternateContent xmlns:mc="http://schemas.openxmlformats.org/markup-compatibility/2006" xmlns:a14="http://schemas.microsoft.com/office/drawing/2010/main">
+        <mc:Choice Requires="a14">
           <p:sp>
             <p:nvSpPr>
               <p:cNvPr id="61" name="TextBox 60">
@@ -13181,7 +13271,7 @@
             </p:txBody>
           </p:sp>
         </mc:Choice>
-        <mc:Fallback>
+        <mc:Fallback xmlns="">
           <p:sp>
             <p:nvSpPr>
               <p:cNvPr id="61" name="TextBox 60">
@@ -13226,8 +13316,8 @@
           </p:sp>
         </mc:Fallback>
       </mc:AlternateContent>
-      <mc:AlternateContent xmlns:mc="http://schemas.openxmlformats.org/markup-compatibility/2006">
-        <mc:Choice xmlns:a14="http://schemas.microsoft.com/office/drawing/2010/main" Requires="a14">
+      <mc:AlternateContent xmlns:mc="http://schemas.openxmlformats.org/markup-compatibility/2006" xmlns:a14="http://schemas.microsoft.com/office/drawing/2010/main">
+        <mc:Choice Requires="a14">
           <p:sp>
             <p:nvSpPr>
               <p:cNvPr id="62" name="TextBox 61">
@@ -13274,7 +13364,7 @@
             </p:txBody>
           </p:sp>
         </mc:Choice>
-        <mc:Fallback>
+        <mc:Fallback xmlns="">
           <p:sp>
             <p:nvSpPr>
               <p:cNvPr id="62" name="TextBox 61">
@@ -14178,8 +14268,8 @@
           </a:fontRef>
         </p:style>
       </p:cxnSp>
-      <mc:AlternateContent xmlns:mc="http://schemas.openxmlformats.org/markup-compatibility/2006">
-        <mc:Choice xmlns:a14="http://schemas.microsoft.com/office/drawing/2010/main" Requires="a14">
+      <mc:AlternateContent xmlns:mc="http://schemas.openxmlformats.org/markup-compatibility/2006" xmlns:a14="http://schemas.microsoft.com/office/drawing/2010/main">
+        <mc:Choice Requires="a14">
           <p:sp>
             <p:nvSpPr>
               <p:cNvPr id="12" name="TextBox 11">
@@ -14241,7 +14331,7 @@
             </p:txBody>
           </p:sp>
         </mc:Choice>
-        <mc:Fallback>
+        <mc:Fallback xmlns="">
           <p:sp>
             <p:nvSpPr>
               <p:cNvPr id="12" name="TextBox 11">
@@ -14286,8 +14376,8 @@
           </p:sp>
         </mc:Fallback>
       </mc:AlternateContent>
-      <mc:AlternateContent xmlns:mc="http://schemas.openxmlformats.org/markup-compatibility/2006">
-        <mc:Choice xmlns:a14="http://schemas.microsoft.com/office/drawing/2010/main" Requires="a14">
+      <mc:AlternateContent xmlns:mc="http://schemas.openxmlformats.org/markup-compatibility/2006" xmlns:a14="http://schemas.microsoft.com/office/drawing/2010/main">
+        <mc:Choice Requires="a14">
           <p:sp>
             <p:nvSpPr>
               <p:cNvPr id="15" name="TextBox 14">
@@ -14349,7 +14439,7 @@
             </p:txBody>
           </p:sp>
         </mc:Choice>
-        <mc:Fallback>
+        <mc:Fallback xmlns="">
           <p:sp>
             <p:nvSpPr>
               <p:cNvPr id="15" name="TextBox 14">
@@ -14394,8 +14484,8 @@
           </p:sp>
         </mc:Fallback>
       </mc:AlternateContent>
-      <mc:AlternateContent xmlns:mc="http://schemas.openxmlformats.org/markup-compatibility/2006">
-        <mc:Choice xmlns:a14="http://schemas.microsoft.com/office/drawing/2010/main" Requires="a14">
+      <mc:AlternateContent xmlns:mc="http://schemas.openxmlformats.org/markup-compatibility/2006" xmlns:a14="http://schemas.microsoft.com/office/drawing/2010/main">
+        <mc:Choice Requires="a14">
           <p:sp>
             <p:nvSpPr>
               <p:cNvPr id="57" name="TextBox 56">
@@ -14683,7 +14773,7 @@
             </p:txBody>
           </p:sp>
         </mc:Choice>
-        <mc:Fallback>
+        <mc:Fallback xmlns="">
           <p:sp>
             <p:nvSpPr>
               <p:cNvPr id="57" name="TextBox 56">
@@ -14929,8 +15019,8 @@
           </p:txBody>
         </p:sp>
       </p:grpSp>
-      <mc:AlternateContent xmlns:mc="http://schemas.openxmlformats.org/markup-compatibility/2006">
-        <mc:Choice xmlns:a14="http://schemas.microsoft.com/office/drawing/2010/main" Requires="a14">
+      <mc:AlternateContent xmlns:mc="http://schemas.openxmlformats.org/markup-compatibility/2006" xmlns:a14="http://schemas.microsoft.com/office/drawing/2010/main">
+        <mc:Choice Requires="a14">
           <p:sp>
             <p:nvSpPr>
               <p:cNvPr id="61" name="TextBox 60">
@@ -14977,7 +15067,7 @@
             </p:txBody>
           </p:sp>
         </mc:Choice>
-        <mc:Fallback>
+        <mc:Fallback xmlns="">
           <p:sp>
             <p:nvSpPr>
               <p:cNvPr id="61" name="TextBox 60">
@@ -15022,8 +15112,8 @@
           </p:sp>
         </mc:Fallback>
       </mc:AlternateContent>
-      <mc:AlternateContent xmlns:mc="http://schemas.openxmlformats.org/markup-compatibility/2006">
-        <mc:Choice xmlns:a14="http://schemas.microsoft.com/office/drawing/2010/main" Requires="a14">
+      <mc:AlternateContent xmlns:mc="http://schemas.openxmlformats.org/markup-compatibility/2006" xmlns:a14="http://schemas.microsoft.com/office/drawing/2010/main">
+        <mc:Choice Requires="a14">
           <p:sp>
             <p:nvSpPr>
               <p:cNvPr id="62" name="TextBox 61">
@@ -15070,7 +15160,7 @@
             </p:txBody>
           </p:sp>
         </mc:Choice>
-        <mc:Fallback>
+        <mc:Fallback xmlns="">
           <p:sp>
             <p:nvSpPr>
               <p:cNvPr id="62" name="TextBox 61">
@@ -15639,8 +15729,8 @@
           </a:p>
         </p:txBody>
       </p:sp>
-      <mc:AlternateContent xmlns:mc="http://schemas.openxmlformats.org/markup-compatibility/2006">
-        <mc:Choice xmlns:a14="http://schemas.microsoft.com/office/drawing/2010/main" Requires="a14">
+      <mc:AlternateContent xmlns:mc="http://schemas.openxmlformats.org/markup-compatibility/2006" xmlns:a14="http://schemas.microsoft.com/office/drawing/2010/main">
+        <mc:Choice Requires="a14">
           <p:sp>
             <p:nvSpPr>
               <p:cNvPr id="76" name="TextBox 75">
@@ -15772,7 +15862,7 @@
             </p:txBody>
           </p:sp>
         </mc:Choice>
-        <mc:Fallback>
+        <mc:Fallback xmlns="">
           <p:sp>
             <p:nvSpPr>
               <p:cNvPr id="76" name="TextBox 75">
@@ -22170,8 +22260,8 @@
           </a:fontRef>
         </p:style>
       </p:cxnSp>
-      <mc:AlternateContent xmlns:mc="http://schemas.openxmlformats.org/markup-compatibility/2006">
-        <mc:Choice xmlns:a14="http://schemas.microsoft.com/office/drawing/2010/main" Requires="a14">
+      <mc:AlternateContent xmlns:mc="http://schemas.openxmlformats.org/markup-compatibility/2006" xmlns:a14="http://schemas.microsoft.com/office/drawing/2010/main">
+        <mc:Choice Requires="a14">
           <p:sp>
             <p:nvSpPr>
               <p:cNvPr id="29" name="TextBox 28">
@@ -22221,7 +22311,7 @@
             </p:txBody>
           </p:sp>
         </mc:Choice>
-        <mc:Fallback>
+        <mc:Fallback xmlns="">
           <p:sp>
             <p:nvSpPr>
               <p:cNvPr id="29" name="TextBox 28">
@@ -22266,8 +22356,8 @@
           </p:sp>
         </mc:Fallback>
       </mc:AlternateContent>
-      <mc:AlternateContent xmlns:mc="http://schemas.openxmlformats.org/markup-compatibility/2006">
-        <mc:Choice xmlns:a14="http://schemas.microsoft.com/office/drawing/2010/main" Requires="a14">
+      <mc:AlternateContent xmlns:mc="http://schemas.openxmlformats.org/markup-compatibility/2006" xmlns:a14="http://schemas.microsoft.com/office/drawing/2010/main">
+        <mc:Choice Requires="a14">
           <p:sp>
             <p:nvSpPr>
               <p:cNvPr id="31" name="TextBox 30">
@@ -22317,7 +22407,7 @@
             </p:txBody>
           </p:sp>
         </mc:Choice>
-        <mc:Fallback>
+        <mc:Fallback xmlns="">
           <p:sp>
             <p:nvSpPr>
               <p:cNvPr id="31" name="TextBox 30">

</xml_diff>